<commit_message>
series_start and series_end support added
</commit_message>
<xml_diff>
--- a/RJDProcessor/doc/package_description/RJDemetra tools for statistical production.pptx
+++ b/RJDProcessor/doc/package_description/RJDemetra tools for statistical production.pptx
@@ -293,7 +293,7 @@
               <a:pPr>
                 <a:defRPr/>
               </a:pPr>
-              <a:t>8/9/2025</a:t>
+              <a:t>12/9/2025</a:t>
             </a:fld>
             <a:endParaRPr lang="en-US"/>
           </a:p>
@@ -10609,7 +10609,7 @@
         <p:spPr>
           <a:xfrm>
             <a:off x="74431" y="1220428"/>
-            <a:ext cx="12067954" cy="481222"/>
+            <a:ext cx="12067954" cy="3065455"/>
           </a:xfrm>
           <a:prstGeom prst="rect">
             <a:avLst/>
@@ -10679,8 +10679,325 @@
             </a:r>
             <a:r>
               <a:rPr lang="it-IT" sz="2300" dirty="0" smtClean="0"/>
-              <a:t> set.</a:t>
-            </a:r>
+              <a:t> set</a:t>
+            </a:r>
+            <a:r>
+              <a:rPr lang="it-IT" sz="2300" dirty="0" smtClean="0"/>
+              <a:t>.</a:t>
+            </a:r>
+          </a:p>
+          <a:p>
+            <a:pPr marL="457200" indent="-457200" algn="just">
+              <a:lnSpc>
+                <a:spcPct val="120000"/>
+              </a:lnSpc>
+              <a:buFont typeface="Courier New" panose="02070309020205020404" pitchFamily="49" charset="0"/>
+              <a:buChar char="o"/>
+            </a:pPr>
+            <a:r>
+              <a:rPr lang="it-IT" sz="2300" b="1" dirty="0" err="1" smtClean="0">
+                <a:solidFill>
+                  <a:srgbClr val="C00000"/>
+                </a:solidFill>
+              </a:rPr>
+              <a:t>series_start</a:t>
+            </a:r>
+            <a:r>
+              <a:rPr lang="it-IT" sz="2300" b="1" dirty="0" smtClean="0">
+                <a:solidFill>
+                  <a:srgbClr val="C00000"/>
+                </a:solidFill>
+              </a:rPr>
+              <a:t> </a:t>
+            </a:r>
+            <a:r>
+              <a:rPr lang="it-IT" sz="2300" b="1" dirty="0" smtClean="0"/>
+              <a:t>and</a:t>
+            </a:r>
+            <a:r>
+              <a:rPr lang="it-IT" sz="2300" b="1" dirty="0" smtClean="0">
+                <a:solidFill>
+                  <a:srgbClr val="C00000"/>
+                </a:solidFill>
+              </a:rPr>
+              <a:t> </a:t>
+            </a:r>
+            <a:r>
+              <a:rPr lang="it-IT" sz="2300" b="1" dirty="0" err="1" smtClean="0">
+                <a:solidFill>
+                  <a:srgbClr val="C00000"/>
+                </a:solidFill>
+              </a:rPr>
+              <a:t>series_end</a:t>
+            </a:r>
+            <a:r>
+              <a:rPr lang="it-IT" sz="2300" dirty="0" smtClean="0"/>
+              <a:t>: </a:t>
+            </a:r>
+            <a:r>
+              <a:rPr lang="it-IT" sz="2300" dirty="0" err="1" smtClean="0"/>
+              <a:t>beginning</a:t>
+            </a:r>
+            <a:r>
+              <a:rPr lang="it-IT" sz="2300" dirty="0" smtClean="0"/>
+              <a:t> and end date of the time </a:t>
+            </a:r>
+            <a:r>
+              <a:rPr lang="it-IT" sz="2300" dirty="0" err="1" smtClean="0"/>
+              <a:t>series</a:t>
+            </a:r>
+            <a:r>
+              <a:rPr lang="it-IT" sz="2300" dirty="0" smtClean="0"/>
+              <a:t>. </a:t>
+            </a:r>
+            <a:r>
+              <a:rPr lang="it-IT" sz="2300" dirty="0" err="1" smtClean="0"/>
+              <a:t>They</a:t>
+            </a:r>
+            <a:r>
+              <a:rPr lang="it-IT" sz="2300" dirty="0" smtClean="0"/>
+              <a:t> </a:t>
+            </a:r>
+            <a:r>
+              <a:rPr lang="it-IT" sz="2300" dirty="0" err="1" smtClean="0"/>
+              <a:t>correspond</a:t>
+            </a:r>
+            <a:r>
+              <a:rPr lang="it-IT" sz="2300" dirty="0" smtClean="0"/>
+              <a:t> to the </a:t>
+            </a:r>
+            <a:r>
+              <a:rPr lang="it-IT" sz="2300" dirty="0" err="1" smtClean="0"/>
+              <a:t>series_span</a:t>
+            </a:r>
+            <a:r>
+              <a:rPr lang="it-IT" sz="2300" dirty="0" smtClean="0"/>
+              <a:t> </a:t>
+            </a:r>
+            <a:r>
+              <a:rPr lang="it-IT" sz="2300" dirty="0" err="1" smtClean="0"/>
+              <a:t>values</a:t>
+            </a:r>
+            <a:r>
+              <a:rPr lang="it-IT" sz="2300" dirty="0" smtClean="0"/>
+              <a:t> of the GUI. NOTE: to </a:t>
+            </a:r>
+            <a:r>
+              <a:rPr lang="it-IT" sz="2300" dirty="0" err="1" smtClean="0"/>
+              <a:t>have</a:t>
+            </a:r>
+            <a:r>
+              <a:rPr lang="it-IT" sz="2300" dirty="0" smtClean="0"/>
+              <a:t> </a:t>
+            </a:r>
+            <a:r>
+              <a:rPr lang="it-IT" sz="2300" dirty="0" err="1" smtClean="0"/>
+              <a:t>this</a:t>
+            </a:r>
+            <a:r>
+              <a:rPr lang="it-IT" sz="2300" dirty="0" smtClean="0"/>
+              <a:t> </a:t>
+            </a:r>
+            <a:r>
+              <a:rPr lang="it-IT" sz="2300" dirty="0" err="1" smtClean="0"/>
+              <a:t>fields</a:t>
+            </a:r>
+            <a:r>
+              <a:rPr lang="it-IT" sz="2300" dirty="0" smtClean="0"/>
+              <a:t> </a:t>
+            </a:r>
+            <a:r>
+              <a:rPr lang="it-IT" sz="2300" dirty="0" err="1" smtClean="0"/>
+              <a:t>setted</a:t>
+            </a:r>
+            <a:r>
+              <a:rPr lang="it-IT" sz="2300" dirty="0" smtClean="0"/>
+              <a:t> by </a:t>
+            </a:r>
+            <a:r>
+              <a:rPr lang="it-IT" sz="2300" dirty="0" err="1" smtClean="0"/>
+              <a:t>reading</a:t>
+            </a:r>
+            <a:r>
+              <a:rPr lang="it-IT" sz="2300" dirty="0" smtClean="0"/>
+              <a:t> a </a:t>
+            </a:r>
+            <a:r>
+              <a:rPr lang="it-IT" sz="2300" dirty="0" err="1"/>
+              <a:t>W</a:t>
+            </a:r>
+            <a:r>
+              <a:rPr lang="it-IT" sz="2300" dirty="0" err="1" smtClean="0"/>
+              <a:t>orkspace</a:t>
+            </a:r>
+            <a:r>
+              <a:rPr lang="it-IT" sz="2300" dirty="0" smtClean="0"/>
+              <a:t> </a:t>
+            </a:r>
+            <a:r>
+              <a:rPr lang="it-IT" sz="2300" dirty="0" err="1" smtClean="0"/>
+              <a:t>produced</a:t>
+            </a:r>
+            <a:r>
+              <a:rPr lang="it-IT" sz="2300" dirty="0" smtClean="0"/>
+              <a:t> by the GUI, </a:t>
+            </a:r>
+            <a:r>
+              <a:rPr lang="it-IT" sz="2300" dirty="0" err="1" smtClean="0"/>
+              <a:t>you</a:t>
+            </a:r>
+            <a:r>
+              <a:rPr lang="it-IT" sz="2300" dirty="0" smtClean="0"/>
+              <a:t> </a:t>
+            </a:r>
+            <a:r>
+              <a:rPr lang="it-IT" sz="2300" dirty="0" err="1" smtClean="0"/>
+              <a:t>need</a:t>
+            </a:r>
+            <a:r>
+              <a:rPr lang="it-IT" sz="2300" dirty="0" smtClean="0"/>
+              <a:t> to set the </a:t>
+            </a:r>
+            <a:r>
+              <a:rPr lang="it-IT" sz="2300" dirty="0" err="1"/>
+              <a:t>S</a:t>
+            </a:r>
+            <a:r>
+              <a:rPr lang="it-IT" sz="2300" dirty="0" err="1" smtClean="0"/>
+              <a:t>pan</a:t>
+            </a:r>
+            <a:r>
+              <a:rPr lang="it-IT" sz="2300" dirty="0" smtClean="0"/>
+              <a:t> with the </a:t>
+            </a:r>
+            <a:r>
+              <a:rPr lang="it-IT" sz="2300" dirty="0" err="1" smtClean="0"/>
+              <a:t>options</a:t>
+            </a:r>
+            <a:r>
+              <a:rPr lang="it-IT" sz="2300" dirty="0" smtClean="0"/>
+              <a:t> "</a:t>
+            </a:r>
+            <a:r>
+              <a:rPr lang="it-IT" sz="2300" b="1" dirty="0"/>
+              <a:t>F</a:t>
+            </a:r>
+            <a:r>
+              <a:rPr lang="it-IT" sz="2300" b="1" dirty="0" smtClean="0"/>
+              <a:t>rom</a:t>
+            </a:r>
+            <a:r>
+              <a:rPr lang="it-IT" sz="2300" dirty="0" smtClean="0"/>
+              <a:t>", "</a:t>
+            </a:r>
+            <a:r>
+              <a:rPr lang="it-IT" sz="2300" b="1" dirty="0" smtClean="0"/>
+              <a:t>To</a:t>
+            </a:r>
+            <a:r>
+              <a:rPr lang="it-IT" sz="2300" dirty="0" smtClean="0"/>
+              <a:t>" or "</a:t>
+            </a:r>
+            <a:r>
+              <a:rPr lang="it-IT" sz="2300" b="1" dirty="0" err="1" smtClean="0"/>
+              <a:t>Between</a:t>
+            </a:r>
+            <a:r>
+              <a:rPr lang="it-IT" sz="2300" dirty="0" smtClean="0"/>
+              <a:t>"; </a:t>
+            </a:r>
+            <a:r>
+              <a:rPr lang="it-IT" sz="2300" dirty="0" err="1" smtClean="0"/>
+              <a:t>other</a:t>
+            </a:r>
+            <a:r>
+              <a:rPr lang="it-IT" sz="2300" dirty="0" smtClean="0"/>
+              <a:t> </a:t>
+            </a:r>
+            <a:r>
+              <a:rPr lang="it-IT" sz="2300" dirty="0" err="1" smtClean="0"/>
+              <a:t>options</a:t>
+            </a:r>
+            <a:r>
+              <a:rPr lang="it-IT" sz="2300" dirty="0" smtClean="0"/>
+              <a:t> (e.g. "</a:t>
+            </a:r>
+            <a:r>
+              <a:rPr lang="it-IT" sz="2300" dirty="0" err="1" smtClean="0"/>
+              <a:t>Exclude</a:t>
+            </a:r>
+            <a:r>
+              <a:rPr lang="it-IT" sz="2300" dirty="0" smtClean="0"/>
+              <a:t> first", "</a:t>
+            </a:r>
+            <a:r>
+              <a:rPr lang="it-IT" sz="2300" dirty="0" err="1" smtClean="0"/>
+              <a:t>Exclude</a:t>
+            </a:r>
+            <a:r>
+              <a:rPr lang="it-IT" sz="2300" dirty="0" smtClean="0"/>
+              <a:t> last" are </a:t>
+            </a:r>
+            <a:r>
+              <a:rPr lang="it-IT" sz="2300" dirty="0" err="1" smtClean="0"/>
+              <a:t>not</a:t>
+            </a:r>
+            <a:r>
+              <a:rPr lang="it-IT" sz="2300" dirty="0" smtClean="0"/>
+              <a:t> </a:t>
+            </a:r>
+            <a:r>
+              <a:rPr lang="it-IT" sz="2300" dirty="0" err="1" smtClean="0"/>
+              <a:t>supported</a:t>
+            </a:r>
+            <a:r>
+              <a:rPr lang="it-IT" sz="2300" dirty="0" smtClean="0"/>
+              <a:t> </a:t>
+            </a:r>
+            <a:r>
+              <a:rPr lang="it-IT" sz="2300" dirty="0" err="1" smtClean="0"/>
+              <a:t>yet</a:t>
+            </a:r>
+            <a:r>
+              <a:rPr lang="it-IT" sz="2300" dirty="0" smtClean="0"/>
+              <a:t>). </a:t>
+            </a:r>
+            <a:r>
+              <a:rPr lang="it-IT" sz="2300" dirty="0" err="1" smtClean="0"/>
+              <a:t>Values</a:t>
+            </a:r>
+            <a:r>
+              <a:rPr lang="it-IT" sz="2300" dirty="0" smtClean="0"/>
+              <a:t> in format </a:t>
+            </a:r>
+          </a:p>
+          <a:p>
+            <a:pPr marL="457200" indent="-457200" algn="just">
+              <a:lnSpc>
+                <a:spcPct val="120000"/>
+              </a:lnSpc>
+              <a:buFont typeface="Courier New" panose="02070309020205020404" pitchFamily="49" charset="0"/>
+              <a:buChar char="o"/>
+            </a:pPr>
+            <a:r>
+              <a:rPr lang="it-IT" sz="2300" dirty="0" smtClean="0"/>
+              <a:t>"2000-12-31</a:t>
+            </a:r>
+            <a:r>
+              <a:rPr lang="it-IT" sz="2300" smtClean="0"/>
+              <a:t>", default = "NA"</a:t>
+            </a:r>
+            <a:endParaRPr lang="it-IT" sz="2300" dirty="0" smtClean="0"/>
+          </a:p>
+          <a:p>
+            <a:pPr marL="457200" indent="-457200" algn="just">
+              <a:lnSpc>
+                <a:spcPct val="120000"/>
+              </a:lnSpc>
+              <a:buFont typeface="Courier New" panose="02070309020205020404" pitchFamily="49" charset="0"/>
+              <a:buChar char="o"/>
+            </a:pPr>
+            <a:endParaRPr lang="it-IT" sz="2300" dirty="0" smtClean="0"/>
           </a:p>
         </p:txBody>
       </p:sp>
@@ -17300,15 +17617,7 @@
                   <a:srgbClr val="C00000"/>
                 </a:solidFill>
               </a:rPr>
-              <a:t>/rjd3</a:t>
-            </a:r>
-            <a:r>
-              <a:rPr lang="it-IT" b="1" dirty="0" smtClean="0">
-                <a:solidFill>
-                  <a:srgbClr val="C00000"/>
-                </a:solidFill>
-              </a:rPr>
-              <a:t>* + </a:t>
+              <a:t>/rjd3* + </a:t>
             </a:r>
             <a:r>
               <a:rPr lang="it-IT" b="1" dirty="0" err="1" smtClean="0">
@@ -31633,15 +31942,6 @@
 
 <file path=customXml/item1.xml><?xml version="1.0" encoding="utf-8"?>
 <?mso-contentType ?>
-<FormTemplates xmlns="http://schemas.microsoft.com/sharepoint/v3/contenttype/forms">
-  <Display>DocumentLibraryForm</Display>
-  <Edit>DocumentLibraryForm</Edit>
-  <New>DocumentLibraryForm</New>
-</FormTemplates>
-</file>
-
-<file path=customXml/item2.xml><?xml version="1.0" encoding="utf-8"?>
-<?mso-contentType ?>
 <spe:Receivers xmlns:spe="http://schemas.microsoft.com/sharepoint/events">
   <Receiver>
     <Name>Document ID Generator</Name>
@@ -31690,22 +31990,16 @@
 </spe:Receivers>
 </file>
 
-<file path=customXml/item3.xml><?xml version="1.0" encoding="utf-8"?>
-<p:properties xmlns:p="http://schemas.microsoft.com/office/2006/metadata/properties" xmlns:xsi="http://www.w3.org/2001/XMLSchema-instance" xmlns:pc="http://schemas.microsoft.com/office/infopath/2007/PartnerControls">
-  <documentManagement>
-    <SottoCategoria xmlns="679261c3-551f-4e86-913f-177e0e529669">-</SottoCategoria>
-    <Categoria xmlns="c58f2efd-82a8-4ecf-b395-8c25e928921d">3- Standard presentazioni Power Point</Categoria>
-    <_dlc_DocId xmlns="459159c4-d20a-4ff3-9b11-fbd127bd52e5">INTRANET-14-174</_dlc_DocId>
-    <_dlc_DocIdUrl xmlns="459159c4-d20a-4ff3-9b11-fbd127bd52e5">
-      <Url>https://intranet.istat.it/Collaborativi/_layouts/15/DocIdRedir.aspx?ID=INTRANET-14-174</Url>
-      <Description>INTRANET-14-174</Description>
-    </_dlc_DocIdUrl>
-    <Ordine xmlns="679261c3-551f-4e86-913f-177e0e529669">1</Ordine>
-  </documentManagement>
-</p:properties>
+<file path=customXml/item2.xml><?xml version="1.0" encoding="utf-8"?>
+<?mso-contentType ?>
+<FormTemplates xmlns="http://schemas.microsoft.com/sharepoint/v3/contenttype/forms">
+  <Display>DocumentLibraryForm</Display>
+  <Edit>DocumentLibraryForm</Edit>
+  <New>DocumentLibraryForm</New>
+</FormTemplates>
 </file>
 
-<file path=customXml/item4.xml><?xml version="1.0" encoding="utf-8"?>
+<file path=customXml/item3.xml><?xml version="1.0" encoding="utf-8"?>
 <ct:contentTypeSchema xmlns:ct="http://schemas.microsoft.com/office/2006/metadata/contentType" xmlns:ma="http://schemas.microsoft.com/office/2006/metadata/properties/metaAttributes" ct:_="" ma:_="" ma:contentTypeName="Documento" ma:contentTypeID="0x010100661A2BE3120D674DA36C11D6006822D4" ma:contentTypeVersion="5" ma:contentTypeDescription="Creare un nuovo documento." ma:contentTypeScope="" ma:versionID="742e6049321d93803bb3bb587f561ffa">
   <xsd:schema xmlns:xsd="http://www.w3.org/2001/XMLSchema" xmlns:xs="http://www.w3.org/2001/XMLSchema" xmlns:p="http://schemas.microsoft.com/office/2006/metadata/properties" xmlns:ns2="c58f2efd-82a8-4ecf-b395-8c25e928921d" xmlns:ns3="459159c4-d20a-4ff3-9b11-fbd127bd52e5" xmlns:ns4="679261c3-551f-4e86-913f-177e0e529669" targetNamespace="http://schemas.microsoft.com/office/2006/metadata/properties" ma:root="true" ma:fieldsID="939ae4a7eaec2950db97a79ca38d2d4d" ns2:_="" ns3:_="" ns4:_="">
     <xsd:import namespace="c58f2efd-82a8-4ecf-b395-8c25e928921d"/>
@@ -31898,7 +32192,30 @@
 </ct:contentTypeSchema>
 </file>
 
+<file path=customXml/item4.xml><?xml version="1.0" encoding="utf-8"?>
+<p:properties xmlns:p="http://schemas.microsoft.com/office/2006/metadata/properties" xmlns:xsi="http://www.w3.org/2001/XMLSchema-instance" xmlns:pc="http://schemas.microsoft.com/office/infopath/2007/PartnerControls">
+  <documentManagement>
+    <SottoCategoria xmlns="679261c3-551f-4e86-913f-177e0e529669">-</SottoCategoria>
+    <Categoria xmlns="c58f2efd-82a8-4ecf-b395-8c25e928921d">3- Standard presentazioni Power Point</Categoria>
+    <_dlc_DocId xmlns="459159c4-d20a-4ff3-9b11-fbd127bd52e5">INTRANET-14-174</_dlc_DocId>
+    <_dlc_DocIdUrl xmlns="459159c4-d20a-4ff3-9b11-fbd127bd52e5">
+      <Url>https://intranet.istat.it/Collaborativi/_layouts/15/DocIdRedir.aspx?ID=INTRANET-14-174</Url>
+      <Description>INTRANET-14-174</Description>
+    </_dlc_DocIdUrl>
+    <Ordine xmlns="679261c3-551f-4e86-913f-177e0e529669">1</Ordine>
+  </documentManagement>
+</p:properties>
+</file>
+
 <file path=customXml/itemProps1.xml><?xml version="1.0" encoding="utf-8"?>
+<ds:datastoreItem xmlns:ds="http://schemas.openxmlformats.org/officeDocument/2006/customXml" ds:itemID="{D9296C4F-9DE9-4B43-AA80-1FC85656CFFA}">
+  <ds:schemaRefs>
+    <ds:schemaRef ds:uri="http://schemas.microsoft.com/sharepoint/events"/>
+  </ds:schemaRefs>
+</ds:datastoreItem>
+</file>
+
+<file path=customXml/itemProps2.xml><?xml version="1.0" encoding="utf-8"?>
 <ds:datastoreItem xmlns:ds="http://schemas.openxmlformats.org/officeDocument/2006/customXml" ds:itemID="{BD9C238D-4D5C-4783-820B-4854DCE45D41}">
   <ds:schemaRefs>
     <ds:schemaRef ds:uri="http://schemas.microsoft.com/sharepoint/v3/contenttype/forms"/>
@@ -31906,33 +32223,7 @@
 </ds:datastoreItem>
 </file>
 
-<file path=customXml/itemProps2.xml><?xml version="1.0" encoding="utf-8"?>
-<ds:datastoreItem xmlns:ds="http://schemas.openxmlformats.org/officeDocument/2006/customXml" ds:itemID="{D9296C4F-9DE9-4B43-AA80-1FC85656CFFA}">
-  <ds:schemaRefs>
-    <ds:schemaRef ds:uri="http://schemas.microsoft.com/sharepoint/events"/>
-  </ds:schemaRefs>
-</ds:datastoreItem>
-</file>
-
 <file path=customXml/itemProps3.xml><?xml version="1.0" encoding="utf-8"?>
-<ds:datastoreItem xmlns:ds="http://schemas.openxmlformats.org/officeDocument/2006/customXml" ds:itemID="{3EF378BC-F4D0-4510-B4EC-07B6EFE18CF8}">
-  <ds:schemaRefs>
-    <ds:schemaRef ds:uri="http://schemas.microsoft.com/office/infopath/2007/PartnerControls"/>
-    <ds:schemaRef ds:uri="http://purl.org/dc/dcmitype/"/>
-    <ds:schemaRef ds:uri="c58f2efd-82a8-4ecf-b395-8c25e928921d"/>
-    <ds:schemaRef ds:uri="http://schemas.microsoft.com/office/2006/metadata/properties"/>
-    <ds:schemaRef ds:uri="http://www.w3.org/XML/1998/namespace"/>
-    <ds:schemaRef ds:uri="http://schemas.microsoft.com/office/2006/documentManagement/types"/>
-    <ds:schemaRef ds:uri="679261c3-551f-4e86-913f-177e0e529669"/>
-    <ds:schemaRef ds:uri="http://purl.org/dc/elements/1.1/"/>
-    <ds:schemaRef ds:uri="http://schemas.openxmlformats.org/package/2006/metadata/core-properties"/>
-    <ds:schemaRef ds:uri="459159c4-d20a-4ff3-9b11-fbd127bd52e5"/>
-    <ds:schemaRef ds:uri="http://purl.org/dc/terms/"/>
-  </ds:schemaRefs>
-</ds:datastoreItem>
-</file>
-
-<file path=customXml/itemProps4.xml><?xml version="1.0" encoding="utf-8"?>
 <ds:datastoreItem xmlns:ds="http://schemas.openxmlformats.org/officeDocument/2006/customXml" ds:itemID="{AA760D03-2285-4F80-B9FC-1F4F97E97129}">
   <ds:schemaRefs>
     <ds:schemaRef ds:uri="http://schemas.microsoft.com/office/2006/metadata/contentType"/>
@@ -31950,4 +32241,22 @@
     <ds:schemaRef ds:uri="http://schemas.microsoft.com/internal/obd"/>
   </ds:schemaRefs>
 </ds:datastoreItem>
+</file>
+
+<file path=customXml/itemProps4.xml><?xml version="1.0" encoding="utf-8"?>
+<ds:datastoreItem xmlns:ds="http://schemas.openxmlformats.org/officeDocument/2006/customXml" ds:itemID="{3EF378BC-F4D0-4510-B4EC-07B6EFE18CF8}">
+  <ds:schemaRefs>
+    <ds:schemaRef ds:uri="http://schemas.microsoft.com/office/infopath/2007/PartnerControls"/>
+    <ds:schemaRef ds:uri="http://purl.org/dc/dcmitype/"/>
+    <ds:schemaRef ds:uri="c58f2efd-82a8-4ecf-b395-8c25e928921d"/>
+    <ds:schemaRef ds:uri="http://schemas.microsoft.com/office/2006/metadata/properties"/>
+    <ds:schemaRef ds:uri="http://www.w3.org/XML/1998/namespace"/>
+    <ds:schemaRef ds:uri="http://schemas.microsoft.com/office/2006/documentManagement/types"/>
+    <ds:schemaRef ds:uri="679261c3-551f-4e86-913f-177e0e529669"/>
+    <ds:schemaRef ds:uri="http://purl.org/dc/elements/1.1/"/>
+    <ds:schemaRef ds:uri="http://schemas.openxmlformats.org/package/2006/metadata/core-properties"/>
+    <ds:schemaRef ds:uri="459159c4-d20a-4ff3-9b11-fbd127bd52e5"/>
+    <ds:schemaRef ds:uri="http://purl.org/dc/terms/"/>
+  </ds:schemaRefs>
+</ds:datastoreItem>
 </file>
</xml_diff>